<commit_message>
Add 8-agent architecture, evaluation scoring, doctor lookup improvements, UI toggles, YouTube PPTX, and data flow diagram
</commit_message>
<xml_diff>
--- a/docs/AI_AgenticAI_MyHealthCoach_Fundamentals.pptx
+++ b/docs/AI_AgenticAI_MyHealthCoach_Fundamentals.pptx
@@ -3123,6 +3123,30 @@
           </a:p>
         </p:txBody>
       </p:sp>
+      <p:pic>
+        <p:nvPicPr>
+          <p:cNvPr id="4" name="Picture 3" descr="logo.png"/>
+          <p:cNvPicPr>
+            <a:picLocks noChangeAspect="1"/>
+          </p:cNvPicPr>
+          <p:nvPr/>
+        </p:nvPicPr>
+        <p:blipFill>
+          <a:blip r:embed="rId2"/>
+          <a:stretch>
+            <a:fillRect/>
+          </a:stretch>
+        </p:blipFill>
+        <p:spPr>
+          <a:xfrm>
+            <a:off x="228600" y="6025896"/>
+            <a:ext cx="2194560" cy="603504"/>
+          </a:xfrm>
+          <a:prstGeom prst="rect">
+            <a:avLst/>
+          </a:prstGeom>
+        </p:spPr>
+      </p:pic>
     </p:spTree>
   </p:cSld>
   <p:clrMapOvr>
@@ -3669,6 +3693,30 @@
           </a:p>
         </p:txBody>
       </p:sp>
+      <p:pic>
+        <p:nvPicPr>
+          <p:cNvPr id="4" name="Picture 3" descr="banner.png"/>
+          <p:cNvPicPr>
+            <a:picLocks noChangeAspect="1"/>
+          </p:cNvPicPr>
+          <p:nvPr/>
+        </p:nvPicPr>
+        <p:blipFill>
+          <a:blip r:embed="rId2"/>
+          <a:stretch>
+            <a:fillRect/>
+          </a:stretch>
+        </p:blipFill>
+        <p:spPr>
+          <a:xfrm>
+            <a:off x="228600" y="6235891"/>
+            <a:ext cx="8686800" cy="1417320"/>
+          </a:xfrm>
+          <a:prstGeom prst="rect">
+            <a:avLst/>
+          </a:prstGeom>
+        </p:spPr>
+      </p:pic>
     </p:spTree>
   </p:cSld>
   <p:clrMapOvr>
@@ -4426,6 +4474,30 @@
           </a:p>
         </p:txBody>
       </p:sp>
+      <p:pic>
+        <p:nvPicPr>
+          <p:cNvPr id="4" name="Picture 3" descr="logo.png"/>
+          <p:cNvPicPr>
+            <a:picLocks noChangeAspect="1"/>
+          </p:cNvPicPr>
+          <p:nvPr/>
+        </p:nvPicPr>
+        <p:blipFill>
+          <a:blip r:embed="rId2"/>
+          <a:stretch>
+            <a:fillRect/>
+          </a:stretch>
+        </p:blipFill>
+        <p:spPr>
+          <a:xfrm>
+            <a:off x="3383280" y="5925312"/>
+            <a:ext cx="2377440" cy="658368"/>
+          </a:xfrm>
+          <a:prstGeom prst="rect">
+            <a:avLst/>
+          </a:prstGeom>
+        </p:spPr>
+      </p:pic>
     </p:spTree>
   </p:cSld>
   <p:clrMapOvr>

</xml_diff>